<commit_message>
Actualizar actividades Tema 4 y Tema 6
</commit_message>
<xml_diff>
--- a/ABD-Tema-4/Actividad 4.2 Reporte de practica_AmauryGordillo_ABD_6ISCM.pptx
+++ b/ABD-Tema-4/Actividad 4.2 Reporte de practica_AmauryGordillo_ABD_6ISCM.pptx
@@ -226,7 +226,7 @@
           <a:p>
             <a:fld id="{C8ED12A0-FE4D-4D61-A54E-8E18C31DAB4E}" type="datetimeFigureOut">
               <a:rPr lang="es-MX" smtClean="0"/>
-              <a:t>31/05/2026</a:t>
+              <a:t>12/06/2026</a:t>
             </a:fld>
             <a:endParaRPr lang="es-MX"/>
           </a:p>
@@ -891,7 +891,7 @@
           <a:p>
             <a:fld id="{5BCAD085-E8A6-8845-BD4E-CB4CCA059FC4}" type="datetimeFigureOut">
               <a:rPr lang="en-US" smtClean="0"/>
-              <a:t>5/31/2026</a:t>
+              <a:t>6/12/2026</a:t>
             </a:fld>
             <a:endParaRPr lang="en-US"/>
           </a:p>
@@ -1059,7 +1059,7 @@
           <a:p>
             <a:fld id="{5BCAD085-E8A6-8845-BD4E-CB4CCA059FC4}" type="datetimeFigureOut">
               <a:rPr lang="en-US" smtClean="0"/>
-              <a:t>5/31/2026</a:t>
+              <a:t>6/12/2026</a:t>
             </a:fld>
             <a:endParaRPr lang="en-US"/>
           </a:p>
@@ -1237,7 +1237,7 @@
           <a:p>
             <a:fld id="{5BCAD085-E8A6-8845-BD4E-CB4CCA059FC4}" type="datetimeFigureOut">
               <a:rPr lang="en-US" smtClean="0"/>
-              <a:t>5/31/2026</a:t>
+              <a:t>6/12/2026</a:t>
             </a:fld>
             <a:endParaRPr lang="en-US"/>
           </a:p>
@@ -1405,7 +1405,7 @@
           <a:p>
             <a:fld id="{5BCAD085-E8A6-8845-BD4E-CB4CCA059FC4}" type="datetimeFigureOut">
               <a:rPr lang="en-US" smtClean="0"/>
-              <a:t>5/31/2026</a:t>
+              <a:t>6/12/2026</a:t>
             </a:fld>
             <a:endParaRPr lang="en-US"/>
           </a:p>
@@ -1650,7 +1650,7 @@
           <a:p>
             <a:fld id="{5BCAD085-E8A6-8845-BD4E-CB4CCA059FC4}" type="datetimeFigureOut">
               <a:rPr lang="en-US" smtClean="0"/>
-              <a:t>5/31/2026</a:t>
+              <a:t>6/12/2026</a:t>
             </a:fld>
             <a:endParaRPr lang="en-US"/>
           </a:p>
@@ -1935,7 +1935,7 @@
           <a:p>
             <a:fld id="{5BCAD085-E8A6-8845-BD4E-CB4CCA059FC4}" type="datetimeFigureOut">
               <a:rPr lang="en-US" smtClean="0"/>
-              <a:t>5/31/2026</a:t>
+              <a:t>6/12/2026</a:t>
             </a:fld>
             <a:endParaRPr lang="en-US"/>
           </a:p>
@@ -2354,7 +2354,7 @@
           <a:p>
             <a:fld id="{5BCAD085-E8A6-8845-BD4E-CB4CCA059FC4}" type="datetimeFigureOut">
               <a:rPr lang="en-US" smtClean="0"/>
-              <a:t>5/31/2026</a:t>
+              <a:t>6/12/2026</a:t>
             </a:fld>
             <a:endParaRPr lang="en-US"/>
           </a:p>
@@ -2471,7 +2471,7 @@
           <a:p>
             <a:fld id="{5BCAD085-E8A6-8845-BD4E-CB4CCA059FC4}" type="datetimeFigureOut">
               <a:rPr lang="en-US" smtClean="0"/>
-              <a:t>5/31/2026</a:t>
+              <a:t>6/12/2026</a:t>
             </a:fld>
             <a:endParaRPr lang="en-US"/>
           </a:p>
@@ -2566,7 +2566,7 @@
           <a:p>
             <a:fld id="{5BCAD085-E8A6-8845-BD4E-CB4CCA059FC4}" type="datetimeFigureOut">
               <a:rPr lang="en-US" smtClean="0"/>
-              <a:t>5/31/2026</a:t>
+              <a:t>6/12/2026</a:t>
             </a:fld>
             <a:endParaRPr lang="en-US"/>
           </a:p>
@@ -2841,7 +2841,7 @@
           <a:p>
             <a:fld id="{5BCAD085-E8A6-8845-BD4E-CB4CCA059FC4}" type="datetimeFigureOut">
               <a:rPr lang="en-US" smtClean="0"/>
-              <a:t>5/31/2026</a:t>
+              <a:t>6/12/2026</a:t>
             </a:fld>
             <a:endParaRPr lang="en-US"/>
           </a:p>
@@ -3093,7 +3093,7 @@
           <a:p>
             <a:fld id="{5BCAD085-E8A6-8845-BD4E-CB4CCA059FC4}" type="datetimeFigureOut">
               <a:rPr lang="en-US" smtClean="0"/>
-              <a:t>5/31/2026</a:t>
+              <a:t>6/12/2026</a:t>
             </a:fld>
             <a:endParaRPr lang="en-US"/>
           </a:p>
@@ -3304,7 +3304,7 @@
           <a:p>
             <a:fld id="{5BCAD085-E8A6-8845-BD4E-CB4CCA059FC4}" type="datetimeFigureOut">
               <a:rPr lang="en-US" smtClean="0"/>
-              <a:t>5/31/2026</a:t>
+              <a:t>6/12/2026</a:t>
             </a:fld>
             <a:endParaRPr lang="en-US"/>
           </a:p>
@@ -9262,7 +9262,7 @@
         </p:nvSpPr>
         <p:spPr>
           <a:xfrm>
-            <a:off x="822960" y="2999232"/>
+            <a:off x="822960" y="3063240"/>
             <a:ext cx="10515600" cy="553998"/>
           </a:xfrm>
           <a:prstGeom prst="rect">
@@ -9285,7 +9285,7 @@
                 <a:latin typeface="Calibri"/>
                 <a:hlinkClick r:id="rId2"/>
               </a:rPr>
-              <a:t>https://github.com/amaurycolochos-cpu/ADMINISTRACION-BASE-DE-DATOS/tree/master/UNIDAD%204/abd-microservicios</a:t>
+              <a:t>https://github.com/amaurycolochos-cpu/ADMINISTRACION-BASE-DE-DATOS/tree/master/ABD-Tema-4</a:t>
             </a:r>
             <a:endParaRPr lang="es-MX" sz="1500" b="1" i="0" dirty="0">
               <a:solidFill>
@@ -9302,176 +9302,6 @@
               </a:solidFill>
               <a:latin typeface="Calibri"/>
             </a:endParaRPr>
-          </a:p>
-        </p:txBody>
-      </p:sp>
-      <p:sp>
-        <p:nvSpPr>
-          <p:cNvPr id="16" name="TextBox 15"/>
-          <p:cNvSpPr txBox="1"/>
-          <p:nvPr/>
-        </p:nvSpPr>
-        <p:spPr>
-          <a:xfrm>
-            <a:off x="548640" y="3822191"/>
-            <a:ext cx="10515600" cy="347472"/>
-          </a:xfrm>
-          <a:prstGeom prst="rect">
-            <a:avLst/>
-          </a:prstGeom>
-          <a:noFill/>
-        </p:spPr>
-        <p:txBody>
-          <a:bodyPr wrap="square">
-            <a:spAutoFit/>
-          </a:bodyPr>
-          <a:lstStyle/>
-          <a:p>
-            <a:pPr algn="l"/>
-            <a:r>
-              <a:rPr sz="1300" b="1" i="0">
-                <a:solidFill>
-                  <a:srgbClr val="00BCD4"/>
-                </a:solidFill>
-                <a:latin typeface="Calibri"/>
-              </a:rPr>
-              <a:t>Estructura del proyecto subido:</a:t>
-            </a:r>
-          </a:p>
-        </p:txBody>
-      </p:sp>
-      <p:sp>
-        <p:nvSpPr>
-          <p:cNvPr id="17" name="TextBox 16"/>
-          <p:cNvSpPr txBox="1"/>
-          <p:nvPr/>
-        </p:nvSpPr>
-        <p:spPr>
-          <a:xfrm>
-            <a:off x="548640" y="4160520"/>
-            <a:ext cx="11109960" cy="2377440"/>
-          </a:xfrm>
-          <a:prstGeom prst="rect">
-            <a:avLst/>
-          </a:prstGeom>
-          <a:noFill/>
-        </p:spPr>
-        <p:txBody>
-          <a:bodyPr wrap="square">
-            <a:spAutoFit/>
-          </a:bodyPr>
-          <a:lstStyle/>
-          <a:p>
-            <a:pPr algn="l">
-              <a:spcBef>
-                <a:spcPts val="300"/>
-              </a:spcBef>
-            </a:pPr>
-            <a:r>
-              <a:rPr sz="1250" b="0">
-                <a:solidFill>
-                  <a:srgbClr val="BBDEFF"/>
-                </a:solidFill>
-                <a:latin typeface="Calibri"/>
-              </a:rPr>
-              <a:t>abd-microservicios/</a:t>
-            </a:r>
-          </a:p>
-          <a:p>
-            <a:pPr algn="l">
-              <a:spcBef>
-                <a:spcPts val="300"/>
-              </a:spcBef>
-            </a:pPr>
-            <a:r>
-              <a:rPr sz="1250" b="0">
-                <a:solidFill>
-                  <a:srgbClr val="BBDEFF"/>
-                </a:solidFill>
-                <a:latin typeface="Calibri"/>
-              </a:rPr>
-              <a:t>  ├─ config-server/     → Servidor de configuración centralizada (puerto 8888)</a:t>
-            </a:r>
-          </a:p>
-          <a:p>
-            <a:pPr algn="l">
-              <a:spcBef>
-                <a:spcPts val="300"/>
-              </a:spcBef>
-            </a:pPr>
-            <a:r>
-              <a:rPr sz="1250" b="0">
-                <a:solidFill>
-                  <a:srgbClr val="BBDEFF"/>
-                </a:solidFill>
-                <a:latin typeface="Calibri"/>
-              </a:rPr>
-              <a:t>  ├─ eureka-server/     → Registro y descubrimiento de servicios (puerto 8761)</a:t>
-            </a:r>
-          </a:p>
-          <a:p>
-            <a:pPr algn="l">
-              <a:spcBef>
-                <a:spcPts val="300"/>
-              </a:spcBef>
-            </a:pPr>
-            <a:r>
-              <a:rPr sz="1250" b="0">
-                <a:solidFill>
-                  <a:srgbClr val="BBDEFF"/>
-                </a:solidFill>
-                <a:latin typeface="Calibri"/>
-              </a:rPr>
-              <a:t>  ├─ api-gateway/       → Punto de entrada único (puerto 8090)</a:t>
-            </a:r>
-          </a:p>
-          <a:p>
-            <a:pPr algn="l">
-              <a:spcBef>
-                <a:spcPts val="300"/>
-              </a:spcBef>
-            </a:pPr>
-            <a:r>
-              <a:rPr sz="1250" b="0">
-                <a:solidFill>
-                  <a:srgbClr val="BBDEFF"/>
-                </a:solidFill>
-                <a:latin typeface="Calibri"/>
-              </a:rPr>
-              <a:t>  ├─ student-service/   → Microservicio estudiantes + MySQL (puerto 8080)</a:t>
-            </a:r>
-          </a:p>
-          <a:p>
-            <a:pPr algn="l">
-              <a:spcBef>
-                <a:spcPts val="300"/>
-              </a:spcBef>
-            </a:pPr>
-            <a:r>
-              <a:rPr sz="1250" b="0">
-                <a:solidFill>
-                  <a:srgbClr val="BBDEFF"/>
-                </a:solidFill>
-                <a:latin typeface="Calibri"/>
-              </a:rPr>
-              <a:t>  ├─ course-service/    → Microservicio cursos + MySQL (puerto 8081)</a:t>
-            </a:r>
-          </a:p>
-          <a:p>
-            <a:pPr algn="l">
-              <a:spcBef>
-                <a:spcPts val="300"/>
-              </a:spcBef>
-            </a:pPr>
-            <a:r>
-              <a:rPr sz="1250" b="0">
-                <a:solidFill>
-                  <a:srgbClr val="BBDEFF"/>
-                </a:solidFill>
-                <a:latin typeface="Calibri"/>
-              </a:rPr>
-              <a:t>  └─ pom.xml            → Proyecto Maven multi-módulo</a:t>
-            </a:r>
           </a:p>
         </p:txBody>
       </p:sp>

</xml_diff>